<commit_message>
Valida de-para CINE x CBO e atualiza apresentação
- de-para: 79 linhas, nenhuma "Verificar"; áreas conferidas pelo nome
  do curso no INEP 2024; coluna fonte com a evidência
- script 04_dim_cbo: cascata em todas as ocupações da CBO e categoria
  pelo grande grupo (nível médio = sobrequalificação); gera dCBO.csv
  e docs/cobertura_depara.csv (99% de cobertura em cargos qualificados)
- apresentação: slides de de-para, métricas e cronograma atualizados;
  novos slides com primeiros resultados e índice por área (2024)
- CLAUDE.md e README dos scripts atualizados

Co-Authored-By: Claude Opus 5.5 <noreply@anthropic.com>
</commit_message>
<xml_diff>
--- a/docs/apresentacao_pi2.pptx
+++ b/docs/apresentacao_pi2.pptx
@@ -13,6 +13,8 @@
     <p:sldId id="261" r:id="rId7"/>
     <p:sldId id="262" r:id="rId8"/>
     <p:sldId id="263" r:id="rId9"/>
+    <p:sldId id="267" r:id="rId18"/>
+    <p:sldId id="268" r:id="rId19"/>
     <p:sldId id="264" r:id="rId10"/>
     <p:sldId id="265" r:id="rId11"/>
     <p:sldId id="266" r:id="rId12"/>
@@ -115,6 +117,203 @@
     </a:lvl9pPr>
   </p:defaultTextStyle>
 </p:presentation>
+</file>
+
+<file path=ppt/charts/chart1.xml><?xml version="1.0" encoding="utf-8"?>
+<c:chartSpace xmlns:c="http://schemas.openxmlformats.org/drawingml/2006/chart" xmlns:a="http://schemas.openxmlformats.org/drawingml/2006/main" xmlns:r="http://schemas.openxmlformats.org/officeDocument/2006/relationships">
+  <c:date1904 val="0"/>
+  <c:chart>
+    <c:autoTitleDeleted val="1"/>
+    <c:plotArea>
+      <c:barChart>
+        <c:barDir val="bar"/>
+        <c:grouping val="clustered"/>
+        <c:ser>
+          <c:idx val="0"/>
+          <c:order val="0"/>
+          <c:tx>
+            <c:strRef>
+              <c:f>Sheet1!$B$1</c:f>
+              <c:strCache>
+                <c:ptCount val="1"/>
+                <c:pt idx="0">
+                  <c:v>Índice</c:v>
+                </c:pt>
+              </c:strCache>
+            </c:strRef>
+          </c:tx>
+          <c:spPr>
+            <a:solidFill>
+              <a:srgbClr val="CFCAEF"/>
+            </a:solidFill>
+          </c:spPr>
+          <c:dPt>
+            <c:idx val="6"/>
+            <c:spPr>
+              <a:solidFill>
+                <a:srgbClr val="F2A541"/>
+              </a:solidFill>
+            </c:spPr>
+          </c:dPt>
+          <c:cat>
+            <c:strRef>
+              <c:f>Sheet1!$A$2:$A$9</c:f>
+              <c:strCache>
+                <c:ptCount val="8"/>
+                <c:pt idx="0">
+                  <c:v>Ciências sociais</c:v>
+                </c:pt>
+                <c:pt idx="1">
+                  <c:v>Educação</c:v>
+                </c:pt>
+                <c:pt idx="2">
+                  <c:v>Artes e humanidades</c:v>
+                </c:pt>
+                <c:pt idx="3">
+                  <c:v>Engenharia</c:v>
+                </c:pt>
+                <c:pt idx="4">
+                  <c:v>Negócios e direito</c:v>
+                </c:pt>
+                <c:pt idx="5">
+                  <c:v>Saúde e bem-estar</c:v>
+                </c:pt>
+                <c:pt idx="6">
+                  <c:v>Computação e TIC</c:v>
+                </c:pt>
+                <c:pt idx="7">
+                  <c:v>Ciências naturais</c:v>
+                </c:pt>
+              </c:strCache>
+            </c:strRef>
+          </c:cat>
+          <c:val>
+            <c:numRef>
+              <c:f>Sheet1!$B$2:$B$9</c:f>
+              <c:numCache>
+                <c:formatCode>General</c:formatCode>
+                <c:ptCount val="8"/>
+                <c:pt idx="0">
+                  <c:v>1.29</c:v>
+                </c:pt>
+                <c:pt idx="1">
+                  <c:v>1.66</c:v>
+                </c:pt>
+                <c:pt idx="2">
+                  <c:v>2.06</c:v>
+                </c:pt>
+                <c:pt idx="3">
+                  <c:v>2.07</c:v>
+                </c:pt>
+                <c:pt idx="4">
+                  <c:v>2.36</c:v>
+                </c:pt>
+                <c:pt idx="5">
+                  <c:v>2.55</c:v>
+                </c:pt>
+                <c:pt idx="6">
+                  <c:v>4.67</c:v>
+                </c:pt>
+                <c:pt idx="7">
+                  <c:v>9.69</c:v>
+                </c:pt>
+              </c:numCache>
+            </c:numRef>
+          </c:val>
+        </c:ser>
+        <c:dLbls>
+          <c:numFmt formatCode="0.0" sourceLinked="0"/>
+          <c:txPr>
+            <a:bodyPr/>
+            <a:lstStyle/>
+            <a:p>
+              <a:pPr>
+                <a:defRPr sz="1100">
+                  <a:solidFill>
+                    <a:srgbClr val="22223A"/>
+                  </a:solidFill>
+                </a:defRPr>
+              </a:pPr>
+            </a:p>
+          </c:txPr>
+          <c:dLblPos val="outEnd"/>
+          <c:showLegendKey val="0"/>
+          <c:showVal val="1"/>
+          <c:showCatName val="0"/>
+          <c:showSerName val="0"/>
+          <c:showPercent val="0"/>
+          <c:showBubbleSize val="0"/>
+          <c:showLeaderLines val="1"/>
+        </c:dLbls>
+        <c:gapWidth val="45"/>
+        <c:axId val="-2068027336"/>
+        <c:axId val="-2113994440"/>
+      </c:barChart>
+      <c:catAx>
+        <c:axId val="-2068027336"/>
+        <c:scaling>
+          <c:orientation val="minMax"/>
+        </c:scaling>
+        <c:delete val="0"/>
+        <c:axPos val="l"/>
+        <c:majorTickMark val="out"/>
+        <c:minorTickMark val="none"/>
+        <c:tickLblPos val="nextTo"/>
+        <c:spPr>
+          <a:ln>
+            <a:noFill/>
+          </a:ln>
+        </c:spPr>
+        <c:txPr>
+          <a:bodyPr/>
+          <a:lstStyle/>
+          <a:p>
+            <a:pPr>
+              <a:defRPr sz="1100">
+                <a:solidFill>
+                  <a:srgbClr val="22223A"/>
+                </a:solidFill>
+              </a:defRPr>
+            </a:pPr>
+          </a:p>
+        </c:txPr>
+        <c:crossAx val="-2113994440"/>
+        <c:crosses val="autoZero"/>
+        <c:auto val="1"/>
+        <c:lblAlgn val="ctr"/>
+        <c:lblOffset val="100"/>
+        <c:noMultiLvlLbl val="0"/>
+      </c:catAx>
+      <c:valAx>
+        <c:axId val="-2113994440"/>
+        <c:scaling>
+          <c:max val="11.0"/>
+        </c:scaling>
+        <c:delete/>
+        <c:axPos val="b"/>
+        <c:majorTickMark val="out"/>
+        <c:minorTickMark val="none"/>
+        <c:tickLblPos val="nextTo"/>
+        <c:crossAx val="-2068027336"/>
+        <c:crosses val="autoZero"/>
+      </c:valAx>
+    </c:plotArea>
+    <c:dispBlanksAs val="gap"/>
+  </c:chart>
+  <c:txPr>
+    <a:bodyPr/>
+    <a:lstStyle/>
+    <a:p>
+      <a:pPr>
+        <a:defRPr sz="1800"/>
+      </a:pPr>
+      <a:endParaRPr lang="en-US"/>
+    </a:p>
+  </c:txPr>
+  <c:externalData r:id="rId1">
+    <c:autoUpdate val="0"/>
+  </c:externalData>
+</c:chartSpace>
 </file>
 
 <file path=ppt/notesMasters/notesMaster1.xml><?xml version="1.0" encoding="utf-8"?>
@@ -599,10 +798,8 @@
           <a:lstStyle/>
           <a:p>
             <a:r>
-              <a:rPr lang="en-US" dirty="0"/>
-              <a:t>Status atual: escopo definido, fontes identificadas e rascunho da tabela de-para pronto. Etapas 1 e 2 em andamento. Ajustar as semanas ao calendário real da disciplina.</a:t>
-            </a:r>
-            <a:endParaRPr lang="en-US" dirty="0"/>
+              <a:t>Status em 30/09/2026: de-para validado e dimensão dCBO gerada; INEP 2024 e CAGED 2024 baixados, filtrados e com primeiros resultados. Falta na coleta: INEP e CAGED de 2020 a 2023, RAIS e IBGE. Falta no modelo: montar o esquema estrela no Power BI. Ajustar as semanas ao calendário real.</a:t>
+            </a:r>
           </a:p>
         </p:txBody>
       </p:sp>
@@ -730,6 +927,146 @@
 </p:notes>
 </file>
 
+<file path=ppt/notesSlides/notesSlide12.xml><?xml version="1.0" encoding="utf-8"?>
+<p:notes xmlns:a="http://schemas.openxmlformats.org/drawingml/2006/main" xmlns:p="http://schemas.openxmlformats.org/presentationml/2006/main" xmlns:r="http://schemas.openxmlformats.org/officeDocument/2006/relationships">
+  <p:cSld>
+    <p:spTree>
+      <p:nvGrpSpPr>
+        <p:cNvPr id="1" name=""/>
+        <p:cNvGrpSpPr/>
+        <p:nvPr/>
+      </p:nvGrpSpPr>
+      <p:grpSpPr>
+        <a:xfrm>
+          <a:off x="0" y="0"/>
+          <a:ext cx="0" cy="0"/>
+          <a:chOff x="0" y="0"/>
+          <a:chExt cx="0" cy="0"/>
+        </a:xfrm>
+      </p:grpSpPr>
+      <p:sp>
+        <p:nvSpPr>
+          <p:cNvPr id="2" name="Slide Image Placeholder 1"/>
+          <p:cNvSpPr>
+            <a:spLocks noGrp="1"/>
+          </p:cNvSpPr>
+          <p:nvPr>
+            <p:ph type="sldImg" idx="2"/>
+          </p:nvPr>
+        </p:nvSpPr>
+        <p:spPr/>
+      </p:sp>
+      <p:sp>
+        <p:nvSpPr>
+          <p:cNvPr id="3" name="Notes Placeholder 2"/>
+          <p:cNvSpPr>
+            <a:spLocks noGrp="1"/>
+          </p:cNvSpPr>
+          <p:nvPr>
+            <p:ph type="body" idx="3" sz="quarter"/>
+          </p:nvPr>
+        </p:nvSpPr>
+        <p:spPr/>
+        <p:txBody>
+          <a:bodyPr/>
+          <a:lstStyle/>
+          <a:p>
+            <a:r>
+              <a:t>Fontes: INEP, Censo da Educação Superior 2024 (arquivo de cursos) e MTE, Novo CAGED jan-dez/2024 (movimentações no prazo). Prêmio salarial por município varia de 1,6× (Carapicuíba e Pirapora) a 2,2× (Itapevi, Osasco e Barueri). A sobrequalificação conversa com o PI1: o diploma protege do desemprego, mas nem sempre leva a uma vaga que exige diploma. Cargos mais comuns: assistente administrativo, auxiliar de logística e auxiliar de escritório.</a:t>
+            </a:r>
+          </a:p>
+        </p:txBody>
+      </p:sp>
+      <p:sp>
+        <p:nvSpPr>
+          <p:cNvPr id="4" name="Slide Number Placeholder 3"/>
+          <p:cNvSpPr>
+            <a:spLocks noGrp="1"/>
+          </p:cNvSpPr>
+          <p:nvPr>
+            <p:ph type="sldNum" idx="5" sz="quarter"/>
+          </p:nvPr>
+        </p:nvSpPr>
+        <p:spPr/>
+      </p:sp>
+    </p:spTree>
+  </p:cSld>
+  <p:clrMapOvr>
+    <a:masterClrMapping/>
+  </p:clrMapOvr>
+</p:notes>
+</file>
+
+<file path=ppt/notesSlides/notesSlide13.xml><?xml version="1.0" encoding="utf-8"?>
+<p:notes xmlns:a="http://schemas.openxmlformats.org/drawingml/2006/main" xmlns:p="http://schemas.openxmlformats.org/presentationml/2006/main" xmlns:r="http://schemas.openxmlformats.org/officeDocument/2006/relationships">
+  <p:cSld>
+    <p:spTree>
+      <p:nvGrpSpPr>
+        <p:cNvPr id="1" name=""/>
+        <p:cNvGrpSpPr/>
+        <p:nvPr/>
+      </p:nvGrpSpPr>
+      <p:grpSpPr>
+        <a:xfrm>
+          <a:off x="0" y="0"/>
+          <a:ext cx="0" cy="0"/>
+          <a:chOff x="0" y="0"/>
+          <a:chExt cx="0" cy="0"/>
+        </a:xfrm>
+      </p:grpSpPr>
+      <p:sp>
+        <p:nvSpPr>
+          <p:cNvPr id="2" name="Slide Image Placeholder 1"/>
+          <p:cNvSpPr>
+            <a:spLocks noGrp="1"/>
+          </p:cNvSpPr>
+          <p:nvPr>
+            <p:ph type="sldImg" idx="2"/>
+          </p:nvPr>
+        </p:nvSpPr>
+        <p:spPr/>
+      </p:sp>
+      <p:sp>
+        <p:nvSpPr>
+          <p:cNvPr id="3" name="Notes Placeholder 2"/>
+          <p:cNvSpPr>
+            <a:spLocks noGrp="1"/>
+          </p:cNvSpPr>
+          <p:nvPr>
+            <p:ph type="body" idx="3" sz="quarter"/>
+          </p:nvPr>
+        </p:nvSpPr>
+        <p:spPr/>
+        <p:txBody>
+          <a:bodyPr/>
+          <a:lstStyle/>
+          <a:p>
+            <a:r>
+              <a:t>Numerador: admissões de pessoas com superior completo ou mais em ocupações cujo vínculo com a área é Principal no de-para (CAGED 2024). Denominador: concluintes da área nos cursos da região (INEP 2024, presencial e EaD). Fora do gráfico: Agricultura (1 concluinte) e Serviços (só ocupações com vínculo secundário). Próximo passo: repetir para 2020 a 2023 e ver a tendência.</a:t>
+            </a:r>
+          </a:p>
+        </p:txBody>
+      </p:sp>
+      <p:sp>
+        <p:nvSpPr>
+          <p:cNvPr id="4" name="Slide Number Placeholder 3"/>
+          <p:cNvSpPr>
+            <a:spLocks noGrp="1"/>
+          </p:cNvSpPr>
+          <p:nvPr>
+            <p:ph type="sldNum" idx="5" sz="quarter"/>
+          </p:nvPr>
+        </p:nvSpPr>
+        <p:spPr/>
+      </p:sp>
+    </p:spTree>
+  </p:cSld>
+  <p:clrMapOvr>
+    <a:masterClrMapping/>
+  </p:clrMapOvr>
+</p:notes>
+</file>
+
 <file path=ppt/notesSlides/notesSlide2.xml><?xml version="1.0" encoding="utf-8"?>
 <p:notes xmlns:a="http://schemas.openxmlformats.org/drawingml/2006/main" xmlns:r="http://schemas.openxmlformats.org/officeDocument/2006/relationships" xmlns:p="http://schemas.openxmlformats.org/presentationml/2006/main">
   <p:cSld>
@@ -1039,10 +1376,8 @@
           <a:lstStyle/>
           <a:p>
             <a:r>
-              <a:rPr lang="en-US" dirty="0"/>
-              <a:t>Fontes: portal de dados abertos do INEP, portal PDET do Ministério do Trabalho e SIDRA do IBGE. Alternativa: Base dos Dados (basedosdados.org) com as bases já tratadas via BigQuery. Os arquivos do CAGED são grandes e serão filtrados em Python antes do Power BI.</a:t>
-            </a:r>
-            <a:endParaRPr lang="en-US" dirty="0"/>
+              <a:t>Fontes: portal de dados abertos do INEP, portal PDET do Ministério do Trabalho e SIDRA do IBGE. Alternativa: Base dos Dados (basedosdados.org) com as bases já tratadas via BigQuery. Os arquivos do CAGED são grandes e serão filtrados em Python antes do Power BI. Conferido no dicionário do INEP 2024: CO_MUNICIPIO é o local de oferta, e os cursos EaD aparecem pelo município do polo. Só 473 concluintes EaD no Brasil vêm sem município.</a:t>
+            </a:r>
           </a:p>
         </p:txBody>
       </p:sp>
@@ -1127,10 +1462,8 @@
           <a:lstStyle/>
           <a:p>
             <a:r>
-              <a:rPr lang="en-US" dirty="0"/>
-              <a:t>A tabela de-para é a principal contribuição metodológica. Rascunho em planilha separada (depara_cine_cbo.xlsx). Próximo passo: validar cada código CBO no site oficial da CBO (MTE) e cada área na documentação CINE Brasil do INEP. Exemplo de limitação: engenheiros de produção recebem formados em Engenharia e em Administração.</a:t>
-            </a:r>
-            <a:endParaRPr lang="en-US" dirty="0"/>
+              <a:t>O rascunho tinha 52 linhas, 18 a verificar. Validamos com as admissões de formados no CAGED 2024 (8 municípios) e com a área CINE dos cursos no INEP 2024: o nome do curso no INEP define a área (ex.: Logística em 04, Educação Física bacharelado em 09). Resultado: 79 linhas, nenhuma a verificar, cobrindo 99% das admissões de formados em cargos de nível superior, técnico ou dirigente. Ocupações dos grandes grupos 4 a 9 (nível médio) ficam sem área de propósito: formado nelas conta como sobrequalificação. A cascata roda no script 04_dim_cbo.py e gera a dimensão dCBO.</a:t>
+            </a:r>
           </a:p>
         </p:txBody>
       </p:sp>
@@ -1303,10 +1636,8 @@
           <a:lstStyle/>
           <a:p>
             <a:r>
-              <a:rPr lang="en-US" dirty="0"/>
-              <a:t>O índice de descompasso é a métrica central. A taxa de conclusão local conecta com o achado do PI1 sobre permanência. O prêmio salarial replica localmente o dado nacional de desemprego por escolaridade.</a:t>
-            </a:r>
-            <a:endParaRPr lang="en-US" dirty="0"/>
+              <a:t>O índice de descompasso é a métrica central. Como as admissões incluem quem troca de emprego e formados de fora da região, o índice fica acima de 1 em todas as áreas; por isso a leitura é comparativa (qual área pressiona mais). O prêmio salarial usa mediana e só salários mensais, sem trabalho intermitente, para não distorcer. Novo indicador surgido na validação: sobrequalificação (formados admitidos em ocupações de nível médio).</a:t>
+            </a:r>
           </a:p>
         </p:txBody>
       </p:sp>
@@ -2054,6 +2385,731 @@
 
 <file path=ppt/slides/slide10.xml><?xml version="1.0" encoding="utf-8"?>
 <p:sld xmlns:a="http://schemas.openxmlformats.org/drawingml/2006/main" xmlns:r="http://schemas.openxmlformats.org/officeDocument/2006/relationships" xmlns:p="http://schemas.openxmlformats.org/presentationml/2006/main">
+  <p:cSld name="Slide 8">
+    <p:spTree>
+      <p:nvGrpSpPr>
+        <p:cNvPr id="1" name=""/>
+        <p:cNvGrpSpPr/>
+        <p:nvPr/>
+      </p:nvGrpSpPr>
+      <p:grpSpPr>
+        <a:xfrm>
+          <a:off x="0" y="0"/>
+          <a:ext cx="0" cy="0"/>
+          <a:chOff x="0" y="0"/>
+          <a:chExt cx="0" cy="0"/>
+        </a:xfrm>
+      </p:grpSpPr>
+      <p:sp>
+        <p:nvSpPr>
+          <p:cNvPr id="2" name="Text 0"/>
+          <p:cNvSpPr txBox="1"/>
+          <p:nvPr/>
+        </p:nvSpPr>
+        <p:spPr>
+          <a:xfrm>
+            <a:off x="457200" y="320040"/>
+            <a:ext cx="8229600" cy="548640"/>
+          </a:xfrm>
+          <a:prstGeom prst="rect">
+            <a:avLst/>
+          </a:prstGeom>
+          <a:noFill/>
+          <a:ln/>
+        </p:spPr>
+        <p:txBody>
+          <a:bodyPr wrap="square" lIns="0" tIns="0" rIns="0" bIns="0" rtlCol="0" anchor="ctr"/>
+          <a:lstStyle/>
+          <a:p>
+            <a:pPr indent="0" marL="0">
+              <a:buNone/>
+            </a:pPr>
+            <a:r>
+              <a:rPr lang="en-US" sz="2800" b="1" dirty="0">
+                <a:solidFill>
+                  <a:srgbClr val="2B2462"/>
+                </a:solidFill>
+                <a:latin typeface="Cambria" pitchFamily="34" charset="0"/>
+                <a:ea typeface="Cambria" pitchFamily="34" charset="-122"/>
+                <a:cs typeface="Cambria" pitchFamily="34" charset="-120"/>
+              </a:rPr>
+              <a:t>Índice de descompasso por área (2024)</a:t>
+            </a:r>
+            <a:endParaRPr lang="en-US" sz="2800" dirty="0"/>
+          </a:p>
+        </p:txBody>
+      </p:sp>
+      <p:sp>
+        <p:nvSpPr>
+          <p:cNvPr id="3" name="Text 1"/>
+          <p:cNvSpPr txBox="1"/>
+          <p:nvPr/>
+        </p:nvSpPr>
+        <p:spPr>
+          <a:xfrm>
+            <a:off x="457200" y="868680"/>
+            <a:ext cx="8229600" cy="320040"/>
+          </a:xfrm>
+          <a:prstGeom prst="rect">
+            <a:avLst/>
+          </a:prstGeom>
+          <a:noFill/>
+          <a:ln/>
+        </p:spPr>
+        <p:txBody>
+          <a:bodyPr wrap="square" lIns="0" tIns="0" rIns="0" bIns="0" rtlCol="0" anchor="ctr"/>
+          <a:lstStyle/>
+          <a:p>
+            <a:pPr indent="0" marL="0">
+              <a:buNone/>
+            </a:pPr>
+            <a:r>
+              <a:rPr lang="en-US" sz="1400" dirty="0">
+                <a:solidFill>
+                  <a:srgbClr val="5E5B78"/>
+                </a:solidFill>
+                <a:latin typeface="Calibri" pitchFamily="34" charset="0"/>
+                <a:ea typeface="Calibri" pitchFamily="34" charset="-122"/>
+                <a:cs typeface="Calibri" pitchFamily="34" charset="-120"/>
+              </a:rPr>
+              <a:t>Admissões de formados em ocupações da área ÷ concluintes da área na região</a:t>
+            </a:r>
+            <a:endParaRPr lang="en-US" sz="1400" dirty="0"/>
+          </a:p>
+        </p:txBody>
+      </p:sp>
+      <p:graphicFrame>
+        <p:nvGraphicFramePr>
+          <p:cNvPr id="4" name="Chart 3"/>
+          <p:cNvGraphicFramePr>
+            <a:graphicFrameLocks noGrp="1"/>
+          </p:cNvGraphicFramePr>
+          <p:nvPr/>
+        </p:nvGraphicFramePr>
+        <p:xfrm>
+          <a:off x="457200" y="1325880"/>
+          <a:ext cx="4937760" cy="3429000"/>
+        </p:xfrm>
+        <a:graphic>
+          <a:graphicData uri="http://schemas.openxmlformats.org/drawingml/2006/chart">
+            <c:chart xmlns:c="http://schemas.openxmlformats.org/drawingml/2006/chart" r:id="rId2"/>
+          </a:graphicData>
+        </a:graphic>
+      </p:graphicFrame>
+      <p:sp>
+        <p:nvSpPr>
+          <p:cNvPr id="5" name="TextBox 4"/>
+          <p:cNvSpPr txBox="1"/>
+          <p:nvPr/>
+        </p:nvSpPr>
+        <p:spPr>
+          <a:xfrm>
+            <a:off x="5669280" y="1417320"/>
+            <a:ext cx="3017520" cy="3291840"/>
+          </a:xfrm>
+          <a:prstGeom prst="rect">
+            <a:avLst/>
+          </a:prstGeom>
+          <a:noFill/>
+        </p:spPr>
+        <p:txBody>
+          <a:bodyPr wrap="square">
+            <a:spAutoFit/>
+          </a:bodyPr>
+          <a:lstStyle/>
+          <a:p>
+            <a:pPr>
+              <a:spcAft>
+                <a:spcPts val="800"/>
+              </a:spcAft>
+            </a:pPr>
+            <a:r>
+              <a:rPr b="1" sz="1200">
+                <a:solidFill>
+                  <a:srgbClr val="2B2462"/>
+                </a:solidFill>
+                <a:latin typeface="Calibri"/>
+              </a:rPr>
+              <a:t>Computação e TIC: </a:t>
+            </a:r>
+            <a:r>
+              <a:rPr sz="1200">
+                <a:solidFill>
+                  <a:srgbClr val="22223A"/>
+                </a:solidFill>
+                <a:latin typeface="Calibri"/>
+              </a:rPr>
+              <a:t>4,7 admissões por concluinte: a maior pressão entre as áreas com muitos formados.</a:t>
+            </a:r>
+          </a:p>
+          <a:p>
+            <a:pPr>
+              <a:spcAft>
+                <a:spcPts val="800"/>
+              </a:spcAft>
+            </a:pPr>
+            <a:r>
+              <a:rPr b="1" sz="1200">
+                <a:solidFill>
+                  <a:srgbClr val="2B2462"/>
+                </a:solidFill>
+                <a:latin typeface="Calibri"/>
+              </a:rPr>
+              <a:t>Ciências naturais: </a:t>
+            </a:r>
+            <a:r>
+              <a:rPr sz="1200">
+                <a:solidFill>
+                  <a:srgbClr val="22223A"/>
+                </a:solidFill>
+                <a:latin typeface="Calibri"/>
+              </a:rPr>
+              <a:t>índice alto, mas com só 72 concluintes na região.</a:t>
+            </a:r>
+          </a:p>
+          <a:p>
+            <a:pPr>
+              <a:spcAft>
+                <a:spcPts val="800"/>
+              </a:spcAft>
+            </a:pPr>
+            <a:r>
+              <a:rPr b="1" sz="1200">
+                <a:solidFill>
+                  <a:srgbClr val="2B2462"/>
+                </a:solidFill>
+                <a:latin typeface="Calibri"/>
+              </a:rPr>
+              <a:t>Ciências sociais e Educação: </a:t>
+            </a:r>
+            <a:r>
+              <a:rPr sz="1200">
+                <a:solidFill>
+                  <a:srgbClr val="22223A"/>
+                </a:solidFill>
+                <a:latin typeface="Calibri"/>
+              </a:rPr>
+              <a:t>menores índices (1,3 e 1,7).</a:t>
+            </a:r>
+          </a:p>
+          <a:p>
+            <a:pPr>
+              <a:spcAft>
+                <a:spcPts val="800"/>
+              </a:spcAft>
+            </a:pPr>
+            <a:r>
+              <a:rPr b="1" sz="1200">
+                <a:solidFill>
+                  <a:srgbClr val="2B2462"/>
+                </a:solidFill>
+                <a:latin typeface="Calibri"/>
+              </a:rPr>
+              <a:t>Por que tudo acima de 1? </a:t>
+            </a:r>
+            <a:r>
+              <a:rPr sz="1200">
+                <a:solidFill>
+                  <a:srgbClr val="22223A"/>
+                </a:solidFill>
+                <a:latin typeface="Calibri"/>
+              </a:rPr>
+              <a:t>a região também contrata formados de fora e recontrata quem já trabalha. Por isso a leitura é comparativa.</a:t>
+            </a:r>
+          </a:p>
+        </p:txBody>
+      </p:sp>
+    </p:spTree>
+  </p:cSld>
+  <p:clrMapOvr>
+    <a:masterClrMapping/>
+  </p:clrMapOvr>
+</p:sld>
+</file>
+
+<file path=ppt/slides/slide11.xml><?xml version="1.0" encoding="utf-8"?>
+<p:sld xmlns:a="http://schemas.openxmlformats.org/drawingml/2006/main" xmlns:r="http://schemas.openxmlformats.org/officeDocument/2006/relationships" xmlns:p="http://schemas.openxmlformats.org/presentationml/2006/main">
+  <p:cSld name="Slide 9">
+    <p:spTree>
+      <p:nvGrpSpPr>
+        <p:cNvPr id="1" name=""/>
+        <p:cNvGrpSpPr/>
+        <p:nvPr/>
+      </p:nvGrpSpPr>
+      <p:grpSpPr>
+        <a:xfrm>
+          <a:off x="0" y="0"/>
+          <a:ext cx="0" cy="0"/>
+          <a:chOff x="0" y="0"/>
+          <a:chExt cx="0" cy="0"/>
+        </a:xfrm>
+      </p:grpSpPr>
+      <p:sp>
+        <p:nvSpPr>
+          <p:cNvPr id="2" name="Text 0"/>
+          <p:cNvSpPr txBox="1"/>
+          <p:nvPr/>
+        </p:nvSpPr>
+        <p:spPr>
+          <a:xfrm>
+            <a:off x="457200" y="320040"/>
+            <a:ext cx="8229600" cy="548640"/>
+          </a:xfrm>
+          <a:prstGeom prst="rect">
+            <a:avLst/>
+          </a:prstGeom>
+          <a:noFill/>
+          <a:ln/>
+        </p:spPr>
+        <p:txBody>
+          <a:bodyPr wrap="square" lIns="0" tIns="0" rIns="0" bIns="0" rtlCol="0" anchor="ctr"/>
+          <a:lstStyle/>
+          <a:p>
+            <a:pPr indent="0" marL="0">
+              <a:buNone/>
+            </a:pPr>
+            <a:r>
+              <a:rPr lang="en-US" sz="2800" b="1" dirty="0">
+                <a:solidFill>
+                  <a:srgbClr val="2B2462"/>
+                </a:solidFill>
+                <a:latin typeface="Cambria" pitchFamily="34" charset="0"/>
+                <a:ea typeface="Cambria" pitchFamily="34" charset="-122"/>
+                <a:cs typeface="Cambria" pitchFamily="34" charset="-120"/>
+              </a:rPr>
+              <a:t>Retorno para a sociedade</a:t>
+            </a:r>
+            <a:endParaRPr lang="en-US" sz="2800" dirty="0"/>
+          </a:p>
+        </p:txBody>
+      </p:sp>
+      <p:sp>
+        <p:nvSpPr>
+          <p:cNvPr id="3" name="Text 1"/>
+          <p:cNvSpPr txBox="1"/>
+          <p:nvPr/>
+        </p:nvSpPr>
+        <p:spPr>
+          <a:xfrm>
+            <a:off x="457200" y="868680"/>
+            <a:ext cx="8229600" cy="320040"/>
+          </a:xfrm>
+          <a:prstGeom prst="rect">
+            <a:avLst/>
+          </a:prstGeom>
+          <a:noFill/>
+          <a:ln/>
+        </p:spPr>
+        <p:txBody>
+          <a:bodyPr wrap="square" lIns="0" tIns="0" rIns="0" bIns="0" rtlCol="0" anchor="ctr"/>
+          <a:lstStyle/>
+          <a:p>
+            <a:pPr indent="0" marL="0">
+              <a:buNone/>
+            </a:pPr>
+            <a:r>
+              <a:rPr lang="en-US" sz="1400" dirty="0">
+                <a:solidFill>
+                  <a:srgbClr val="5E5B78"/>
+                </a:solidFill>
+                <a:latin typeface="Calibri" pitchFamily="34" charset="0"/>
+                <a:ea typeface="Calibri" pitchFamily="34" charset="-122"/>
+                <a:cs typeface="Calibri" pitchFamily="34" charset="-120"/>
+              </a:rPr>
+              <a:t>Atende à orientação do MEC de extensão universitária</a:t>
+            </a:r>
+            <a:endParaRPr lang="en-US" sz="1400" dirty="0"/>
+          </a:p>
+        </p:txBody>
+      </p:sp>
+      <p:sp>
+        <p:nvSpPr>
+          <p:cNvPr id="4" name="Shape 2"/>
+          <p:cNvSpPr/>
+          <p:nvPr/>
+        </p:nvSpPr>
+        <p:spPr>
+          <a:xfrm>
+            <a:off x="457200" y="1371600"/>
+            <a:ext cx="4023360" cy="3200400"/>
+          </a:xfrm>
+          <a:prstGeom prst="roundRect">
+            <a:avLst>
+              <a:gd name="adj" fmla="val 2286"/>
+            </a:avLst>
+          </a:prstGeom>
+          <a:solidFill>
+            <a:srgbClr val="2B2462"/>
+          </a:solidFill>
+          <a:ln w="12700">
+            <a:solidFill>
+              <a:srgbClr val="2B2462"/>
+            </a:solidFill>
+            <a:prstDash val="solid"/>
+          </a:ln>
+        </p:spPr>
+      </p:sp>
+      <p:sp>
+        <p:nvSpPr>
+          <p:cNvPr id="5" name="Text 3"/>
+          <p:cNvSpPr txBox="1"/>
+          <p:nvPr/>
+        </p:nvSpPr>
+        <p:spPr>
+          <a:xfrm>
+            <a:off x="731520" y="1554480"/>
+            <a:ext cx="3474720" cy="320040"/>
+          </a:xfrm>
+          <a:prstGeom prst="rect">
+            <a:avLst/>
+          </a:prstGeom>
+          <a:noFill/>
+          <a:ln/>
+        </p:spPr>
+        <p:txBody>
+          <a:bodyPr wrap="square" lIns="0" tIns="0" rIns="0" bIns="0" rtlCol="0" anchor="ctr"/>
+          <a:lstStyle/>
+          <a:p>
+            <a:pPr indent="0" marL="0">
+              <a:buNone/>
+            </a:pPr>
+            <a:r>
+              <a:rPr lang="en-US" sz="1300" b="1" dirty="0">
+                <a:solidFill>
+                  <a:srgbClr val="F2A541"/>
+                </a:solidFill>
+                <a:latin typeface="Calibri" pitchFamily="34" charset="0"/>
+                <a:ea typeface="Calibri" pitchFamily="34" charset="-122"/>
+                <a:cs typeface="Calibri" pitchFamily="34" charset="-120"/>
+              </a:rPr>
+              <a:t>Produto</a:t>
+            </a:r>
+            <a:endParaRPr lang="en-US" sz="1300" dirty="0"/>
+          </a:p>
+        </p:txBody>
+      </p:sp>
+      <p:sp>
+        <p:nvSpPr>
+          <p:cNvPr id="6" name="Text 4"/>
+          <p:cNvSpPr txBox="1"/>
+          <p:nvPr/>
+        </p:nvSpPr>
+        <p:spPr>
+          <a:xfrm>
+            <a:off x="731520" y="1874520"/>
+            <a:ext cx="3474720" cy="822960"/>
+          </a:xfrm>
+          <a:prstGeom prst="rect">
+            <a:avLst/>
+          </a:prstGeom>
+          <a:noFill/>
+          <a:ln/>
+        </p:spPr>
+        <p:txBody>
+          <a:bodyPr wrap="square" lIns="0" tIns="0" rIns="0" bIns="0" rtlCol="0" anchor="t"/>
+          <a:lstStyle/>
+          <a:p>
+            <a:pPr indent="0" marL="0">
+              <a:buNone/>
+            </a:pPr>
+            <a:r>
+              <a:rPr lang="en-US" sz="2000" b="1" dirty="0">
+                <a:solidFill>
+                  <a:srgbClr val="FFFFFF"/>
+                </a:solidFill>
+                <a:latin typeface="Cambria" pitchFamily="34" charset="0"/>
+                <a:ea typeface="Cambria" pitchFamily="34" charset="-122"/>
+                <a:cs typeface="Cambria" pitchFamily="34" charset="-120"/>
+              </a:rPr>
+              <a:t>Guia "Cursos com mercado na nossa região"</a:t>
+            </a:r>
+            <a:endParaRPr lang="en-US" sz="2000" dirty="0"/>
+          </a:p>
+        </p:txBody>
+      </p:sp>
+      <p:sp>
+        <p:nvSpPr>
+          <p:cNvPr id="7" name="Text 5"/>
+          <p:cNvSpPr txBox="1"/>
+          <p:nvPr/>
+        </p:nvSpPr>
+        <p:spPr>
+          <a:xfrm>
+            <a:off x="731520" y="2743200"/>
+            <a:ext cx="3474720" cy="914400"/>
+          </a:xfrm>
+          <a:prstGeom prst="rect">
+            <a:avLst/>
+          </a:prstGeom>
+          <a:noFill/>
+          <a:ln/>
+        </p:spPr>
+        <p:txBody>
+          <a:bodyPr wrap="square" lIns="0" tIns="0" rIns="0" bIns="0" rtlCol="0" anchor="t"/>
+          <a:lstStyle/>
+          <a:p>
+            <a:pPr indent="0" marL="0">
+              <a:buNone/>
+            </a:pPr>
+            <a:r>
+              <a:rPr lang="en-US" sz="1300" dirty="0">
+                <a:solidFill>
+                  <a:srgbClr val="CFCAEF"/>
+                </a:solidFill>
+                <a:latin typeface="Calibri" pitchFamily="34" charset="0"/>
+                <a:ea typeface="Calibri" pitchFamily="34" charset="-122"/>
+                <a:cs typeface="Calibri" pitchFamily="34" charset="-120"/>
+              </a:rPr>
+              <a:t>Uma a duas páginas, linguagem para estudantes do ensino médio, com link para o dashboard público no Power BI.</a:t>
+            </a:r>
+            <a:endParaRPr lang="en-US" sz="1300" dirty="0"/>
+          </a:p>
+        </p:txBody>
+      </p:sp>
+      <p:sp>
+        <p:nvSpPr>
+          <p:cNvPr id="8" name="Text 6"/>
+          <p:cNvSpPr txBox="1"/>
+          <p:nvPr/>
+        </p:nvSpPr>
+        <p:spPr>
+          <a:xfrm>
+            <a:off x="4754880" y="1371600"/>
+            <a:ext cx="3931920" cy="320040"/>
+          </a:xfrm>
+          <a:prstGeom prst="rect">
+            <a:avLst/>
+          </a:prstGeom>
+          <a:noFill/>
+          <a:ln/>
+        </p:spPr>
+        <p:txBody>
+          <a:bodyPr wrap="square" lIns="0" tIns="0" rIns="0" bIns="0" rtlCol="0" anchor="ctr"/>
+          <a:lstStyle/>
+          <a:p>
+            <a:pPr indent="0" marL="0">
+              <a:buNone/>
+            </a:pPr>
+            <a:r>
+              <a:rPr lang="en-US" sz="1500" b="1" dirty="0">
+                <a:solidFill>
+                  <a:srgbClr val="2B2462"/>
+                </a:solidFill>
+                <a:latin typeface="Cambria" pitchFamily="34" charset="0"/>
+                <a:ea typeface="Cambria" pitchFamily="34" charset="-122"/>
+                <a:cs typeface="Cambria" pitchFamily="34" charset="-120"/>
+              </a:rPr>
+              <a:t>Destinatários</a:t>
+            </a:r>
+            <a:endParaRPr lang="en-US" sz="1500" dirty="0"/>
+          </a:p>
+        </p:txBody>
+      </p:sp>
+      <p:sp>
+        <p:nvSpPr>
+          <p:cNvPr id="9" name="Text 7"/>
+          <p:cNvSpPr txBox="1"/>
+          <p:nvPr/>
+        </p:nvSpPr>
+        <p:spPr>
+          <a:xfrm>
+            <a:off x="4754880" y="1709928"/>
+            <a:ext cx="3931920" cy="640080"/>
+          </a:xfrm>
+          <a:prstGeom prst="rect">
+            <a:avLst/>
+          </a:prstGeom>
+          <a:noFill/>
+          <a:ln/>
+        </p:spPr>
+        <p:txBody>
+          <a:bodyPr wrap="square" lIns="0" tIns="0" rIns="0" bIns="0" rtlCol="0" anchor="t"/>
+          <a:lstStyle/>
+          <a:p>
+            <a:pPr indent="0" marL="0">
+              <a:buNone/>
+            </a:pPr>
+            <a:r>
+              <a:rPr lang="en-US" sz="1200" dirty="0">
+                <a:solidFill>
+                  <a:srgbClr val="22223A"/>
+                </a:solidFill>
+                <a:latin typeface="Calibri" pitchFamily="34" charset="0"/>
+                <a:ea typeface="Calibri" pitchFamily="34" charset="-122"/>
+                <a:cs typeface="Calibri" pitchFamily="34" charset="-120"/>
+              </a:rPr>
+              <a:t>Diretoria de Ensino da região (escolas estaduais) e coordenação da Fatec Santana de Parnaíba</a:t>
+            </a:r>
+            <a:endParaRPr lang="en-US" sz="1200" dirty="0"/>
+          </a:p>
+        </p:txBody>
+      </p:sp>
+      <p:sp>
+        <p:nvSpPr>
+          <p:cNvPr id="10" name="Text 8"/>
+          <p:cNvSpPr txBox="1"/>
+          <p:nvPr/>
+        </p:nvSpPr>
+        <p:spPr>
+          <a:xfrm>
+            <a:off x="4754880" y="2468880"/>
+            <a:ext cx="3931920" cy="320040"/>
+          </a:xfrm>
+          <a:prstGeom prst="rect">
+            <a:avLst/>
+          </a:prstGeom>
+          <a:noFill/>
+          <a:ln/>
+        </p:spPr>
+        <p:txBody>
+          <a:bodyPr wrap="square" lIns="0" tIns="0" rIns="0" bIns="0" rtlCol="0" anchor="ctr"/>
+          <a:lstStyle/>
+          <a:p>
+            <a:pPr indent="0" marL="0">
+              <a:buNone/>
+            </a:pPr>
+            <a:r>
+              <a:rPr lang="en-US" sz="1500" b="1" dirty="0">
+                <a:solidFill>
+                  <a:srgbClr val="2B2462"/>
+                </a:solidFill>
+                <a:latin typeface="Cambria" pitchFamily="34" charset="0"/>
+                <a:ea typeface="Cambria" pitchFamily="34" charset="-122"/>
+                <a:cs typeface="Cambria" pitchFamily="34" charset="-120"/>
+              </a:rPr>
+              <a:t>Entrega</a:t>
+            </a:r>
+            <a:endParaRPr lang="en-US" sz="1500" dirty="0"/>
+          </a:p>
+        </p:txBody>
+      </p:sp>
+      <p:sp>
+        <p:nvSpPr>
+          <p:cNvPr id="11" name="Text 9"/>
+          <p:cNvSpPr txBox="1"/>
+          <p:nvPr/>
+        </p:nvSpPr>
+        <p:spPr>
+          <a:xfrm>
+            <a:off x="4754880" y="2807208"/>
+            <a:ext cx="3931920" cy="640080"/>
+          </a:xfrm>
+          <a:prstGeom prst="rect">
+            <a:avLst/>
+          </a:prstGeom>
+          <a:noFill/>
+          <a:ln/>
+        </p:spPr>
+        <p:txBody>
+          <a:bodyPr wrap="square" lIns="0" tIns="0" rIns="0" bIns="0" rtlCol="0" anchor="t"/>
+          <a:lstStyle/>
+          <a:p>
+            <a:pPr indent="0" marL="0">
+              <a:buNone/>
+            </a:pPr>
+            <a:r>
+              <a:rPr lang="en-US" sz="1200" dirty="0">
+                <a:solidFill>
+                  <a:srgbClr val="22223A"/>
+                </a:solidFill>
+                <a:latin typeface="Calibri" pitchFamily="34" charset="0"/>
+                <a:ea typeface="Calibri" pitchFamily="34" charset="-122"/>
+                <a:cs typeface="Calibri" pitchFamily="34" charset="-120"/>
+              </a:rPr>
+              <a:t>Ofício ou e-mail institucional, sem necessidade de visita de campo</a:t>
+            </a:r>
+            <a:endParaRPr lang="en-US" sz="1200" dirty="0"/>
+          </a:p>
+        </p:txBody>
+      </p:sp>
+      <p:sp>
+        <p:nvSpPr>
+          <p:cNvPr id="12" name="Text 10"/>
+          <p:cNvSpPr txBox="1"/>
+          <p:nvPr/>
+        </p:nvSpPr>
+        <p:spPr>
+          <a:xfrm>
+            <a:off x="4754880" y="3566160"/>
+            <a:ext cx="3931920" cy="320040"/>
+          </a:xfrm>
+          <a:prstGeom prst="rect">
+            <a:avLst/>
+          </a:prstGeom>
+          <a:noFill/>
+          <a:ln/>
+        </p:spPr>
+        <p:txBody>
+          <a:bodyPr wrap="square" lIns="0" tIns="0" rIns="0" bIns="0" rtlCol="0" anchor="ctr"/>
+          <a:lstStyle/>
+          <a:p>
+            <a:pPr indent="0" marL="0">
+              <a:buNone/>
+            </a:pPr>
+            <a:r>
+              <a:rPr lang="en-US" sz="1500" b="1" dirty="0">
+                <a:solidFill>
+                  <a:srgbClr val="2B2462"/>
+                </a:solidFill>
+                <a:latin typeface="Cambria" pitchFamily="34" charset="0"/>
+                <a:ea typeface="Cambria" pitchFamily="34" charset="-122"/>
+                <a:cs typeface="Cambria" pitchFamily="34" charset="-120"/>
+              </a:rPr>
+              <a:t>Evidências</a:t>
+            </a:r>
+            <a:endParaRPr lang="en-US" sz="1500" dirty="0"/>
+          </a:p>
+        </p:txBody>
+      </p:sp>
+      <p:sp>
+        <p:nvSpPr>
+          <p:cNvPr id="13" name="Text 11"/>
+          <p:cNvSpPr txBox="1"/>
+          <p:nvPr/>
+        </p:nvSpPr>
+        <p:spPr>
+          <a:xfrm>
+            <a:off x="4754880" y="3904488"/>
+            <a:ext cx="3931920" cy="640080"/>
+          </a:xfrm>
+          <a:prstGeom prst="rect">
+            <a:avLst/>
+          </a:prstGeom>
+          <a:noFill/>
+          <a:ln/>
+        </p:spPr>
+        <p:txBody>
+          <a:bodyPr wrap="square" lIns="0" tIns="0" rIns="0" bIns="0" rtlCol="0" anchor="t"/>
+          <a:lstStyle/>
+          <a:p>
+            <a:pPr indent="0" marL="0">
+              <a:buNone/>
+            </a:pPr>
+            <a:r>
+              <a:rPr lang="en-US" sz="1200" dirty="0">
+                <a:solidFill>
+                  <a:srgbClr val="22223A"/>
+                </a:solidFill>
+                <a:latin typeface="Calibri" pitchFamily="34" charset="0"/>
+                <a:ea typeface="Calibri" pitchFamily="34" charset="-122"/>
+                <a:cs typeface="Calibri" pitchFamily="34" charset="-120"/>
+              </a:rPr>
+              <a:t>Comprovante de envio, repositório GitHub, prints das etapas e dashboard publicado</a:t>
+            </a:r>
+            <a:endParaRPr lang="en-US" sz="1200" dirty="0"/>
+          </a:p>
+        </p:txBody>
+      </p:sp>
+    </p:spTree>
+  </p:cSld>
+  <p:clrMapOvr>
+    <a:masterClrMapping/>
+  </p:clrMapOvr>
+</p:sld>
+</file>
+
+<file path=ppt/slides/slide12.xml><?xml version="1.0" encoding="utf-8"?>
+<p:sld xmlns:a="http://schemas.openxmlformats.org/drawingml/2006/main" xmlns:r="http://schemas.openxmlformats.org/officeDocument/2006/relationships" xmlns:p="http://schemas.openxmlformats.org/presentationml/2006/main">
   <p:cSld name="Slide 10">
     <p:spTree>
       <p:nvGrpSpPr>
@@ -3248,7 +4304,7 @@
                 <a:ea typeface="Calibri" pitchFamily="34" charset="-122"/>
                 <a:cs typeface="Calibri" pitchFamily="34" charset="-120"/>
               </a:rPr>
-              <a:t>Concluído: escopo, fontes identificadas, rascunho do de-para</a:t>
+              <a:t>Concluído: de-para validado; INEP 2024 e CAGED 2024 tratados</a:t>
             </a:r>
             <a:endParaRPr lang="en-US" sz="1100" dirty="0"/>
           </a:p>
@@ -3390,7 +4446,7 @@
 </p:sld>
 </file>
 
-<file path=ppt/slides/slide11.xml><?xml version="1.0" encoding="utf-8"?>
+<file path=ppt/slides/slide13.xml><?xml version="1.0" encoding="utf-8"?>
 <p:sld xmlns:a="http://schemas.openxmlformats.org/drawingml/2006/main" xmlns:r="http://schemas.openxmlformats.org/officeDocument/2006/relationships" xmlns:p="http://schemas.openxmlformats.org/presentationml/2006/main">
   <p:cSld name="Slide 11">
     <p:bg>
@@ -7054,7 +8110,7 @@
                 <a:ea typeface="Cambria" pitchFamily="34" charset="-122"/>
                 <a:cs typeface="Cambria" pitchFamily="34" charset="-120"/>
               </a:rPr>
-              <a:t>52</a:t>
+              <a:t>79</a:t>
             </a:r>
             <a:endParaRPr lang="en-US" sz="3600" dirty="0"/>
           </a:p>
@@ -7093,7 +8149,7 @@
                 <a:ea typeface="Calibri" pitchFamily="34" charset="-122"/>
                 <a:cs typeface="Calibri" pitchFamily="34" charset="-120"/>
               </a:rPr>
-              <a:t>ocupações mapeadas no rascunho</a:t>
+              <a:t>linhas no de-para validado</a:t>
             </a:r>
             <a:endParaRPr lang="en-US" sz="1200" dirty="0"/>
           </a:p>
@@ -7210,7 +8266,7 @@
                 <a:ea typeface="Cambria" pitchFamily="34" charset="-122"/>
                 <a:cs typeface="Cambria" pitchFamily="34" charset="-120"/>
               </a:rPr>
-              <a:t>18</a:t>
+              <a:t>99%</a:t>
             </a:r>
             <a:endParaRPr lang="en-US" sz="3600" dirty="0"/>
           </a:p>
@@ -7249,7 +8305,7 @@
                 <a:ea typeface="Calibri" pitchFamily="34" charset="-122"/>
                 <a:cs typeface="Calibri" pitchFamily="34" charset="-120"/>
               </a:rPr>
-              <a:t>linhas a verificar</a:t>
+              <a:t>dos formados em cargos qualificados</a:t>
             </a:r>
             <a:endParaRPr lang="en-US" sz="1200" dirty="0"/>
           </a:p>
@@ -7288,7 +8344,7 @@
                 <a:ea typeface="Calibri" pitchFamily="34" charset="-122"/>
                 <a:cs typeface="Calibri" pitchFamily="34" charset="-120"/>
               </a:rPr>
-              <a:t>Busca em cascata: 4 dígitos da CBO, depois 3, 2 e 1. Limitação: ocupações que recebem formados de várias áreas.</a:t>
+              <a:t>Validado com CAGED e INEP 2024. Limitação: ocupações que recebem formados de várias áreas.</a:t>
             </a:r>
             <a:endParaRPr lang="en-US" sz="1100" dirty="0"/>
           </a:p>
@@ -8364,7 +9420,7 @@
                 <a:ea typeface="Calibri" pitchFamily="34" charset="-122"/>
                 <a:cs typeface="Calibri" pitchFamily="34" charset="-120"/>
               </a:rPr>
-              <a:t>Admissões com superior na área ÷ concluintes na área. Acima de 1: falta profissional; abaixo de 1: excesso de formados.</a:t>
+              <a:t>Admissões com superior na área ÷ concluintes na área. Leitura comparativa entre áreas.</a:t>
             </a:r>
             <a:endParaRPr lang="en-US" sz="1200" dirty="0"/>
           </a:p>
@@ -8533,7 +9589,7 @@
                 <a:ea typeface="Calibri" pitchFamily="34" charset="-122"/>
                 <a:cs typeface="Calibri" pitchFamily="34" charset="-120"/>
               </a:rPr>
-              <a:t>Salário médio de admissão com superior ÷ salário médio com ensino médio.</a:t>
+              <a:t>Salário mediano de admissão com superior ÷ com ensino médio. Só salário mensal, sem intermitente.</a:t>
             </a:r>
             <a:endParaRPr lang="en-US" sz="1200" dirty="0"/>
           </a:p>
@@ -8887,7 +9943,7 @@
 
 <file path=ppt/slides/slide9.xml><?xml version="1.0" encoding="utf-8"?>
 <p:sld xmlns:a="http://schemas.openxmlformats.org/drawingml/2006/main" xmlns:r="http://schemas.openxmlformats.org/officeDocument/2006/relationships" xmlns:p="http://schemas.openxmlformats.org/presentationml/2006/main">
-  <p:cSld name="Slide 9">
+  <p:cSld name="Slide 2">
     <p:spTree>
       <p:nvGrpSpPr>
         <p:cNvPr id="1" name=""/>
@@ -8935,7 +9991,7 @@
                 <a:ea typeface="Cambria" pitchFamily="34" charset="-122"/>
                 <a:cs typeface="Cambria" pitchFamily="34" charset="-120"/>
               </a:rPr>
-              <a:t>Retorno para a sociedade</a:t>
+              <a:t>Primeiros resultados (2024)</a:t>
             </a:r>
             <a:endParaRPr lang="en-US" sz="2800" dirty="0"/>
           </a:p>
@@ -8974,7 +10030,7 @@
                 <a:ea typeface="Calibri" pitchFamily="34" charset="-122"/>
                 <a:cs typeface="Calibri" pitchFamily="34" charset="-120"/>
               </a:rPr>
-              <a:t>Atende à orientação do MEC de extensão universitária</a:t>
+              <a:t>INEP e CAGED 2024 nos 8 municípios do recorte</a:t>
             </a:r>
             <a:endParaRPr lang="en-US" sz="1400" dirty="0"/>
           </a:p>
@@ -8982,18 +10038,252 @@
       </p:sp>
       <p:sp>
         <p:nvSpPr>
-          <p:cNvPr id="4" name="Shape 2"/>
+          <p:cNvPr id="4" name="Text 2"/>
+          <p:cNvSpPr txBox="1"/>
+          <p:nvPr/>
+        </p:nvSpPr>
+        <p:spPr>
+          <a:xfrm>
+            <a:off x="457200" y="1371600"/>
+            <a:ext cx="2286000" cy="822960"/>
+          </a:xfrm>
+          <a:prstGeom prst="rect">
+            <a:avLst/>
+          </a:prstGeom>
+          <a:noFill/>
+          <a:ln/>
+        </p:spPr>
+        <p:txBody>
+          <a:bodyPr wrap="square" lIns="0" tIns="0" rIns="0" bIns="0" rtlCol="0" anchor="ctr"/>
+          <a:lstStyle/>
+          <a:p>
+            <a:pPr indent="0" marL="0">
+              <a:buNone/>
+            </a:pPr>
+            <a:r>
+              <a:rPr lang="en-US" sz="2600" b="1" dirty="0">
+                <a:solidFill>
+                  <a:srgbClr val="2B2462"/>
+                </a:solidFill>
+                <a:latin typeface="Cambria" pitchFamily="34" charset="0"/>
+                <a:ea typeface="Cambria" pitchFamily="34" charset="-122"/>
+                <a:cs typeface="Cambria" pitchFamily="34" charset="-120"/>
+              </a:rPr>
+              <a:t>13,6 mil</a:t>
+            </a:r>
+            <a:endParaRPr lang="en-US" sz="2600" dirty="0"/>
+          </a:p>
+        </p:txBody>
+      </p:sp>
+      <p:sp>
+        <p:nvSpPr>
+          <p:cNvPr id="5" name="Text 3"/>
+          <p:cNvSpPr txBox="1"/>
+          <p:nvPr/>
+        </p:nvSpPr>
+        <p:spPr>
+          <a:xfrm>
+            <a:off x="2788920" y="1371600"/>
+            <a:ext cx="2286000" cy="822960"/>
+          </a:xfrm>
+          <a:prstGeom prst="rect">
+            <a:avLst/>
+          </a:prstGeom>
+          <a:noFill/>
+          <a:ln/>
+        </p:spPr>
+        <p:txBody>
+          <a:bodyPr wrap="square" lIns="0" tIns="0" rIns="0" bIns="0" rtlCol="0" anchor="ctr"/>
+          <a:lstStyle/>
+          <a:p>
+            <a:pPr indent="0" marL="0">
+              <a:buNone/>
+            </a:pPr>
+            <a:r>
+              <a:rPr lang="en-US" sz="1300" dirty="0">
+                <a:solidFill>
+                  <a:srgbClr val="22223A"/>
+                </a:solidFill>
+                <a:latin typeface="Calibri" pitchFamily="34" charset="0"/>
+                <a:ea typeface="Calibri" pitchFamily="34" charset="-122"/>
+                <a:cs typeface="Calibri" pitchFamily="34" charset="-120"/>
+              </a:rPr>
+              <a:t>concluintes; 91% na rede privada e 67% em EaD</a:t>
+            </a:r>
+            <a:endParaRPr lang="en-US" sz="1300" dirty="0"/>
+          </a:p>
+        </p:txBody>
+      </p:sp>
+      <p:sp>
+        <p:nvSpPr>
+          <p:cNvPr id="6" name="Text 4"/>
+          <p:cNvSpPr txBox="1"/>
+          <p:nvPr/>
+        </p:nvSpPr>
+        <p:spPr>
+          <a:xfrm>
+            <a:off x="457200" y="2423160"/>
+            <a:ext cx="2286000" cy="822960"/>
+          </a:xfrm>
+          <a:prstGeom prst="rect">
+            <a:avLst/>
+          </a:prstGeom>
+          <a:noFill/>
+          <a:ln/>
+        </p:spPr>
+        <p:txBody>
+          <a:bodyPr wrap="square" lIns="0" tIns="0" rIns="0" bIns="0" rtlCol="0" anchor="ctr"/>
+          <a:lstStyle/>
+          <a:p>
+            <a:pPr indent="0" marL="0">
+              <a:buNone/>
+            </a:pPr>
+            <a:r>
+              <a:rPr lang="en-US" sz="2600" b="1" dirty="0">
+                <a:solidFill>
+                  <a:srgbClr val="2B2462"/>
+                </a:solidFill>
+                <a:latin typeface="Cambria" pitchFamily="34" charset="0"/>
+                <a:ea typeface="Cambria" pitchFamily="34" charset="-122"/>
+                <a:cs typeface="Cambria" pitchFamily="34" charset="-120"/>
+              </a:rPr>
+              <a:t>73,2 mil</a:t>
+            </a:r>
+            <a:endParaRPr lang="en-US" sz="2600" dirty="0"/>
+          </a:p>
+        </p:txBody>
+      </p:sp>
+      <p:sp>
+        <p:nvSpPr>
+          <p:cNvPr id="7" name="Text 5"/>
+          <p:cNvSpPr txBox="1"/>
+          <p:nvPr/>
+        </p:nvSpPr>
+        <p:spPr>
+          <a:xfrm>
+            <a:off x="2788920" y="2423160"/>
+            <a:ext cx="2286000" cy="822960"/>
+          </a:xfrm>
+          <a:prstGeom prst="rect">
+            <a:avLst/>
+          </a:prstGeom>
+          <a:noFill/>
+          <a:ln/>
+        </p:spPr>
+        <p:txBody>
+          <a:bodyPr wrap="square" lIns="0" tIns="0" rIns="0" bIns="0" rtlCol="0" anchor="ctr"/>
+          <a:lstStyle/>
+          <a:p>
+            <a:pPr indent="0" marL="0">
+              <a:buNone/>
+            </a:pPr>
+            <a:r>
+              <a:rPr lang="en-US" sz="1300" dirty="0">
+                <a:solidFill>
+                  <a:srgbClr val="22223A"/>
+                </a:solidFill>
+                <a:latin typeface="Calibri" pitchFamily="34" charset="0"/>
+                <a:ea typeface="Calibri" pitchFamily="34" charset="-122"/>
+                <a:cs typeface="Calibri" pitchFamily="34" charset="-120"/>
+              </a:rPr>
+              <a:t>admissões de formados, 14% de todas as admissões</a:t>
+            </a:r>
+            <a:endParaRPr lang="en-US" sz="1300" dirty="0"/>
+          </a:p>
+        </p:txBody>
+      </p:sp>
+      <p:sp>
+        <p:nvSpPr>
+          <p:cNvPr id="8" name="Text 6"/>
+          <p:cNvSpPr txBox="1"/>
+          <p:nvPr/>
+        </p:nvSpPr>
+        <p:spPr>
+          <a:xfrm>
+            <a:off x="457200" y="3474720"/>
+            <a:ext cx="2286000" cy="822960"/>
+          </a:xfrm>
+          <a:prstGeom prst="rect">
+            <a:avLst/>
+          </a:prstGeom>
+          <a:noFill/>
+          <a:ln/>
+        </p:spPr>
+        <p:txBody>
+          <a:bodyPr wrap="square" lIns="0" tIns="0" rIns="0" bIns="0" rtlCol="0" anchor="ctr"/>
+          <a:lstStyle/>
+          <a:p>
+            <a:pPr indent="0" marL="0">
+              <a:buNone/>
+            </a:pPr>
+            <a:r>
+              <a:rPr lang="en-US" sz="2600" b="1" dirty="0">
+                <a:solidFill>
+                  <a:srgbClr val="2B2462"/>
+                </a:solidFill>
+                <a:latin typeface="Cambria" pitchFamily="34" charset="0"/>
+                <a:ea typeface="Cambria" pitchFamily="34" charset="-122"/>
+                <a:cs typeface="Cambria" pitchFamily="34" charset="-120"/>
+              </a:rPr>
+              <a:t>2,1×</a:t>
+            </a:r>
+            <a:endParaRPr lang="en-US" sz="2600" dirty="0"/>
+          </a:p>
+        </p:txBody>
+      </p:sp>
+      <p:sp>
+        <p:nvSpPr>
+          <p:cNvPr id="9" name="Text 7"/>
+          <p:cNvSpPr txBox="1"/>
+          <p:nvPr/>
+        </p:nvSpPr>
+        <p:spPr>
+          <a:xfrm>
+            <a:off x="2788920" y="3474720"/>
+            <a:ext cx="2286000" cy="822960"/>
+          </a:xfrm>
+          <a:prstGeom prst="rect">
+            <a:avLst/>
+          </a:prstGeom>
+          <a:noFill/>
+          <a:ln/>
+        </p:spPr>
+        <p:txBody>
+          <a:bodyPr wrap="square" lIns="0" tIns="0" rIns="0" bIns="0" rtlCol="0" anchor="ctr"/>
+          <a:lstStyle/>
+          <a:p>
+            <a:pPr indent="0" marL="0">
+              <a:buNone/>
+            </a:pPr>
+            <a:r>
+              <a:rPr lang="en-US" sz="1300" dirty="0">
+                <a:solidFill>
+                  <a:srgbClr val="22223A"/>
+                </a:solidFill>
+                <a:latin typeface="Calibri" pitchFamily="34" charset="0"/>
+                <a:ea typeface="Calibri" pitchFamily="34" charset="-122"/>
+                <a:cs typeface="Calibri" pitchFamily="34" charset="-120"/>
+              </a:rPr>
+              <a:t>prêmio salarial: mediana de R$ 3.841 com superior e R$ 1.850 com médio</a:t>
+            </a:r>
+            <a:endParaRPr lang="en-US" sz="1300" dirty="0"/>
+          </a:p>
+        </p:txBody>
+      </p:sp>
+      <p:sp>
+        <p:nvSpPr>
+          <p:cNvPr id="10" name="Shape 8"/>
           <p:cNvSpPr/>
           <p:nvPr/>
         </p:nvSpPr>
         <p:spPr>
           <a:xfrm>
-            <a:off x="457200" y="1371600"/>
-            <a:ext cx="4023360" cy="3200400"/>
+            <a:off x="5303520" y="1371600"/>
+            <a:ext cx="3383280" cy="2971800"/>
           </a:xfrm>
           <a:prstGeom prst="roundRect">
             <a:avLst>
-              <a:gd name="adj" fmla="val 2286"/>
+              <a:gd name="adj" fmla="val 2462"/>
             </a:avLst>
           </a:prstGeom>
           <a:solidFill>
@@ -9009,14 +10299,14 @@
       </p:sp>
       <p:sp>
         <p:nvSpPr>
-          <p:cNvPr id="5" name="Text 3"/>
-          <p:cNvSpPr txBox="1"/>
-          <p:nvPr/>
-        </p:nvSpPr>
-        <p:spPr>
-          <a:xfrm>
-            <a:off x="731520" y="1554480"/>
-            <a:ext cx="3474720" cy="320040"/>
+          <p:cNvPr id="11" name="Text 9"/>
+          <p:cNvSpPr txBox="1"/>
+          <p:nvPr/>
+        </p:nvSpPr>
+        <p:spPr>
+          <a:xfrm>
+            <a:off x="5532120" y="1554480"/>
+            <a:ext cx="2926080" cy="365760"/>
           </a:xfrm>
           <a:prstGeom prst="rect">
             <a:avLst/>
@@ -9040,7 +10330,7 @@
                 <a:ea typeface="Calibri" pitchFamily="34" charset="-122"/>
                 <a:cs typeface="Calibri" pitchFamily="34" charset="-120"/>
               </a:rPr>
-              <a:t>Produto</a:t>
+              <a:t>Achado inicial</a:t>
             </a:r>
             <a:endParaRPr lang="en-US" sz="1300" dirty="0"/>
           </a:p>
@@ -9048,14 +10338,14 @@
       </p:sp>
       <p:sp>
         <p:nvSpPr>
-          <p:cNvPr id="6" name="Text 4"/>
-          <p:cNvSpPr txBox="1"/>
-          <p:nvPr/>
-        </p:nvSpPr>
-        <p:spPr>
-          <a:xfrm>
-            <a:off x="731520" y="1874520"/>
-            <a:ext cx="3474720" cy="822960"/>
+          <p:cNvPr id="12" name="Text 10"/>
+          <p:cNvSpPr txBox="1"/>
+          <p:nvPr/>
+        </p:nvSpPr>
+        <p:spPr>
+          <a:xfrm>
+            <a:off x="5532120" y="1965960"/>
+            <a:ext cx="2926080" cy="1554480"/>
           </a:xfrm>
           <a:prstGeom prst="rect">
             <a:avLst/>
@@ -9071,7 +10361,7 @@
               <a:buNone/>
             </a:pPr>
             <a:r>
-              <a:rPr lang="en-US" sz="2000" b="1" dirty="0">
+              <a:rPr lang="en-US" sz="1600" dirty="0">
                 <a:solidFill>
                   <a:srgbClr val="FFFFFF"/>
                 </a:solidFill>
@@ -9079,38 +10369,38 @@
                 <a:ea typeface="Cambria" pitchFamily="34" charset="-122"/>
                 <a:cs typeface="Cambria" pitchFamily="34" charset="-120"/>
               </a:rPr>
-              <a:t>Guia "Cursos com mercado na nossa região"</a:t>
-            </a:r>
-            <a:endParaRPr lang="en-US" sz="2000" dirty="0"/>
-          </a:p>
-        </p:txBody>
-      </p:sp>
-      <p:sp>
-        <p:nvSpPr>
-          <p:cNvPr id="7" name="Text 5"/>
-          <p:cNvSpPr txBox="1"/>
-          <p:nvPr/>
-        </p:nvSpPr>
-        <p:spPr>
-          <a:xfrm>
-            <a:off x="731520" y="2743200"/>
-            <a:ext cx="3474720" cy="914400"/>
-          </a:xfrm>
-          <a:prstGeom prst="rect">
-            <a:avLst/>
-          </a:prstGeom>
-          <a:noFill/>
-          <a:ln/>
-        </p:spPr>
-        <p:txBody>
-          <a:bodyPr wrap="square" lIns="0" tIns="0" rIns="0" bIns="0" rtlCol="0" anchor="t"/>
-          <a:lstStyle/>
-          <a:p>
-            <a:pPr indent="0" marL="0">
-              <a:buNone/>
-            </a:pPr>
-            <a:r>
-              <a:rPr lang="en-US" sz="1300" dirty="0">
+              <a:t>1 em cada 3 formados contratados na região entra em vaga de nível médio.</a:t>
+            </a:r>
+            <a:endParaRPr lang="en-US" sz="1600" dirty="0"/>
+          </a:p>
+        </p:txBody>
+      </p:sp>
+      <p:sp>
+        <p:nvSpPr>
+          <p:cNvPr id="13" name="Text 11"/>
+          <p:cNvSpPr txBox="1"/>
+          <p:nvPr/>
+        </p:nvSpPr>
+        <p:spPr>
+          <a:xfrm>
+            <a:off x="5532120" y="3749040"/>
+            <a:ext cx="2926080" cy="365760"/>
+          </a:xfrm>
+          <a:prstGeom prst="rect">
+            <a:avLst/>
+          </a:prstGeom>
+          <a:noFill/>
+          <a:ln/>
+        </p:spPr>
+        <p:txBody>
+          <a:bodyPr wrap="square" lIns="0" tIns="0" rIns="0" bIns="0" rtlCol="0" anchor="ctr"/>
+          <a:lstStyle/>
+          <a:p>
+            <a:pPr indent="0" marL="0">
+              <a:buNone/>
+            </a:pPr>
+            <a:r>
+              <a:rPr lang="en-US" sz="1200" i="1" dirty="0">
                 <a:solidFill>
                   <a:srgbClr val="CFCAEF"/>
                 </a:solidFill>
@@ -9118,241 +10408,7 @@
                 <a:ea typeface="Calibri" pitchFamily="34" charset="-122"/>
                 <a:cs typeface="Calibri" pitchFamily="34" charset="-120"/>
               </a:rPr>
-              <a:t>Uma a duas páginas, linguagem para estudantes do ensino médio, com link para o dashboard público no Power BI.</a:t>
-            </a:r>
-            <a:endParaRPr lang="en-US" sz="1300" dirty="0"/>
-          </a:p>
-        </p:txBody>
-      </p:sp>
-      <p:sp>
-        <p:nvSpPr>
-          <p:cNvPr id="8" name="Text 6"/>
-          <p:cNvSpPr txBox="1"/>
-          <p:nvPr/>
-        </p:nvSpPr>
-        <p:spPr>
-          <a:xfrm>
-            <a:off x="4754880" y="1371600"/>
-            <a:ext cx="3931920" cy="320040"/>
-          </a:xfrm>
-          <a:prstGeom prst="rect">
-            <a:avLst/>
-          </a:prstGeom>
-          <a:noFill/>
-          <a:ln/>
-        </p:spPr>
-        <p:txBody>
-          <a:bodyPr wrap="square" lIns="0" tIns="0" rIns="0" bIns="0" rtlCol="0" anchor="ctr"/>
-          <a:lstStyle/>
-          <a:p>
-            <a:pPr indent="0" marL="0">
-              <a:buNone/>
-            </a:pPr>
-            <a:r>
-              <a:rPr lang="en-US" sz="1500" b="1" dirty="0">
-                <a:solidFill>
-                  <a:srgbClr val="2B2462"/>
-                </a:solidFill>
-                <a:latin typeface="Cambria" pitchFamily="34" charset="0"/>
-                <a:ea typeface="Cambria" pitchFamily="34" charset="-122"/>
-                <a:cs typeface="Cambria" pitchFamily="34" charset="-120"/>
-              </a:rPr>
-              <a:t>Destinatários</a:t>
-            </a:r>
-            <a:endParaRPr lang="en-US" sz="1500" dirty="0"/>
-          </a:p>
-        </p:txBody>
-      </p:sp>
-      <p:sp>
-        <p:nvSpPr>
-          <p:cNvPr id="9" name="Text 7"/>
-          <p:cNvSpPr txBox="1"/>
-          <p:nvPr/>
-        </p:nvSpPr>
-        <p:spPr>
-          <a:xfrm>
-            <a:off x="4754880" y="1709928"/>
-            <a:ext cx="3931920" cy="640080"/>
-          </a:xfrm>
-          <a:prstGeom prst="rect">
-            <a:avLst/>
-          </a:prstGeom>
-          <a:noFill/>
-          <a:ln/>
-        </p:spPr>
-        <p:txBody>
-          <a:bodyPr wrap="square" lIns="0" tIns="0" rIns="0" bIns="0" rtlCol="0" anchor="t"/>
-          <a:lstStyle/>
-          <a:p>
-            <a:pPr indent="0" marL="0">
-              <a:buNone/>
-            </a:pPr>
-            <a:r>
-              <a:rPr lang="en-US" sz="1200" dirty="0">
-                <a:solidFill>
-                  <a:srgbClr val="22223A"/>
-                </a:solidFill>
-                <a:latin typeface="Calibri" pitchFamily="34" charset="0"/>
-                <a:ea typeface="Calibri" pitchFamily="34" charset="-122"/>
-                <a:cs typeface="Calibri" pitchFamily="34" charset="-120"/>
-              </a:rPr>
-              <a:t>Diretoria de Ensino da região (escolas estaduais) e coordenação da Fatec Santana de Parnaíba</a:t>
-            </a:r>
-            <a:endParaRPr lang="en-US" sz="1200" dirty="0"/>
-          </a:p>
-        </p:txBody>
-      </p:sp>
-      <p:sp>
-        <p:nvSpPr>
-          <p:cNvPr id="10" name="Text 8"/>
-          <p:cNvSpPr txBox="1"/>
-          <p:nvPr/>
-        </p:nvSpPr>
-        <p:spPr>
-          <a:xfrm>
-            <a:off x="4754880" y="2468880"/>
-            <a:ext cx="3931920" cy="320040"/>
-          </a:xfrm>
-          <a:prstGeom prst="rect">
-            <a:avLst/>
-          </a:prstGeom>
-          <a:noFill/>
-          <a:ln/>
-        </p:spPr>
-        <p:txBody>
-          <a:bodyPr wrap="square" lIns="0" tIns="0" rIns="0" bIns="0" rtlCol="0" anchor="ctr"/>
-          <a:lstStyle/>
-          <a:p>
-            <a:pPr indent="0" marL="0">
-              <a:buNone/>
-            </a:pPr>
-            <a:r>
-              <a:rPr lang="en-US" sz="1500" b="1" dirty="0">
-                <a:solidFill>
-                  <a:srgbClr val="2B2462"/>
-                </a:solidFill>
-                <a:latin typeface="Cambria" pitchFamily="34" charset="0"/>
-                <a:ea typeface="Cambria" pitchFamily="34" charset="-122"/>
-                <a:cs typeface="Cambria" pitchFamily="34" charset="-120"/>
-              </a:rPr>
-              <a:t>Entrega</a:t>
-            </a:r>
-            <a:endParaRPr lang="en-US" sz="1500" dirty="0"/>
-          </a:p>
-        </p:txBody>
-      </p:sp>
-      <p:sp>
-        <p:nvSpPr>
-          <p:cNvPr id="11" name="Text 9"/>
-          <p:cNvSpPr txBox="1"/>
-          <p:nvPr/>
-        </p:nvSpPr>
-        <p:spPr>
-          <a:xfrm>
-            <a:off x="4754880" y="2807208"/>
-            <a:ext cx="3931920" cy="640080"/>
-          </a:xfrm>
-          <a:prstGeom prst="rect">
-            <a:avLst/>
-          </a:prstGeom>
-          <a:noFill/>
-          <a:ln/>
-        </p:spPr>
-        <p:txBody>
-          <a:bodyPr wrap="square" lIns="0" tIns="0" rIns="0" bIns="0" rtlCol="0" anchor="t"/>
-          <a:lstStyle/>
-          <a:p>
-            <a:pPr indent="0" marL="0">
-              <a:buNone/>
-            </a:pPr>
-            <a:r>
-              <a:rPr lang="en-US" sz="1200" dirty="0">
-                <a:solidFill>
-                  <a:srgbClr val="22223A"/>
-                </a:solidFill>
-                <a:latin typeface="Calibri" pitchFamily="34" charset="0"/>
-                <a:ea typeface="Calibri" pitchFamily="34" charset="-122"/>
-                <a:cs typeface="Calibri" pitchFamily="34" charset="-120"/>
-              </a:rPr>
-              <a:t>Ofício ou e-mail institucional, sem necessidade de visita de campo</a:t>
-            </a:r>
-            <a:endParaRPr lang="en-US" sz="1200" dirty="0"/>
-          </a:p>
-        </p:txBody>
-      </p:sp>
-      <p:sp>
-        <p:nvSpPr>
-          <p:cNvPr id="12" name="Text 10"/>
-          <p:cNvSpPr txBox="1"/>
-          <p:nvPr/>
-        </p:nvSpPr>
-        <p:spPr>
-          <a:xfrm>
-            <a:off x="4754880" y="3566160"/>
-            <a:ext cx="3931920" cy="320040"/>
-          </a:xfrm>
-          <a:prstGeom prst="rect">
-            <a:avLst/>
-          </a:prstGeom>
-          <a:noFill/>
-          <a:ln/>
-        </p:spPr>
-        <p:txBody>
-          <a:bodyPr wrap="square" lIns="0" tIns="0" rIns="0" bIns="0" rtlCol="0" anchor="ctr"/>
-          <a:lstStyle/>
-          <a:p>
-            <a:pPr indent="0" marL="0">
-              <a:buNone/>
-            </a:pPr>
-            <a:r>
-              <a:rPr lang="en-US" sz="1500" b="1" dirty="0">
-                <a:solidFill>
-                  <a:srgbClr val="2B2462"/>
-                </a:solidFill>
-                <a:latin typeface="Cambria" pitchFamily="34" charset="0"/>
-                <a:ea typeface="Cambria" pitchFamily="34" charset="-122"/>
-                <a:cs typeface="Cambria" pitchFamily="34" charset="-120"/>
-              </a:rPr>
-              <a:t>Evidências</a:t>
-            </a:r>
-            <a:endParaRPr lang="en-US" sz="1500" dirty="0"/>
-          </a:p>
-        </p:txBody>
-      </p:sp>
-      <p:sp>
-        <p:nvSpPr>
-          <p:cNvPr id="13" name="Text 11"/>
-          <p:cNvSpPr txBox="1"/>
-          <p:nvPr/>
-        </p:nvSpPr>
-        <p:spPr>
-          <a:xfrm>
-            <a:off x="4754880" y="3904488"/>
-            <a:ext cx="3931920" cy="640080"/>
-          </a:xfrm>
-          <a:prstGeom prst="rect">
-            <a:avLst/>
-          </a:prstGeom>
-          <a:noFill/>
-          <a:ln/>
-        </p:spPr>
-        <p:txBody>
-          <a:bodyPr wrap="square" lIns="0" tIns="0" rIns="0" bIns="0" rtlCol="0" anchor="t"/>
-          <a:lstStyle/>
-          <a:p>
-            <a:pPr indent="0" marL="0">
-              <a:buNone/>
-            </a:pPr>
-            <a:r>
-              <a:rPr lang="en-US" sz="1200" dirty="0">
-                <a:solidFill>
-                  <a:srgbClr val="22223A"/>
-                </a:solidFill>
-                <a:latin typeface="Calibri" pitchFamily="34" charset="0"/>
-                <a:ea typeface="Calibri" pitchFamily="34" charset="-122"/>
-                <a:cs typeface="Calibri" pitchFamily="34" charset="-120"/>
-              </a:rPr>
-              <a:t>Comprovante de envio, repositório GitHub, prints das etapas e dashboard publicado</a:t>
+              <a:t>Sobrequalificação: 34% das admissões com diploma</a:t>
             </a:r>
             <a:endParaRPr lang="en-US" sz="1200" dirty="0"/>
           </a:p>

</xml_diff>